<commit_message>
docs(presentacion): corregir datos tecnicos y carreteras en PPTX y web (ronda 2)
</commit_message>
<xml_diff>
--- a/docs/proyecto2/presentacion/Presentacion_Transporte_Express.pptx
+++ b/docs/proyecto2/presentacion/Presentacion_Transporte_Express.pptx
@@ -589,7 +589,7 @@
           <a:p/>
           <a:p>
             <a:r>
-              <a:t>En aseguramiento de calidad de software, ejecutamos 148 pruebas automatizadas End-to-End con Playwright en 4 dispositivos y motores de renderizado (Chromium, WebKit, Firefox y vista móvil) con 100 % de éxito. Finalmente, la auditoría oficial de Google Lighthouse certificó un rendimiento de 91, accesibilidad de 95, mejores prácticas de 100 y SEO de 100.</a:t>
+              <a:t>En aseguramiento de calidad de software, ejecutamos 148 pruebas automatizadas End-to-End con Playwright en 4 dispositivos (Desktop Chrome, iPhone 13 en WebKit, Pixel 7 e iPad) con 100 % de éxito. Finalmente, la auditoría oficial de Google Lighthouse certificó un rendimiento de 91, accesibilidad de 95, mejores prácticas de 100 y SEO de 100.</a:t>
             </a:r>
           </a:p>
         </p:txBody>
@@ -978,13 +978,19 @@
           <a:lstStyle/>
           <a:p>
             <a:r>
-              <a:t>Un aspecto fundamental de nuestro trabajo fue garantizar que los datos fueran 100 % reales y auditables. Extrajimos las distancias y geometrías mediante el motor OSRM sobre OpenStreetMap y validamos manualmente las 49 carreteras frente a Google Maps. El resultado fue contundente: 35 tramos con coincidencia idéntica, 9 con variación menor a 2 km y 5 con ajustes documentados por trazados urbanos o libramientos recientes.</a:t>
+              <a:t>Un aspecto fundamental de nuestro trabajo fue garantizar que los datos fueran 100 % reales y auditables. Extrajimos las distancias y geometrías mediante el motor OSRM sobre OpenStreetMap y validamos manualmente las 49 carreteras frente a Google Maps bajo un criterio técnico de tolerancia a ±10 %:</a:t>
             </a:r>
           </a:p>
           <a:p/>
           <a:p>
             <a:r>
-              <a:t>Un hallazgo crítico fue la arista Izabal–Petén de 287.0 km por la CA-13: sin esta arteria troncal directa, cualquier algoritmo desviaría absurdamente los viajes por Alta Verapaz aumentando cientos de kilómetros innecesarios. Cada número en nuestro sistema proviene de carreteras reales de Guatemala.</a:t>
+              <a:t>35 tramos con OSRM a ±10 % de la ruta recomendada por Google Maps; 9 tramos con OSRM a ±10 % de una ruta alternativa que ofrece Google Maps; y 5 tramos donde ninguna coincidió (CHI-SOL, CHI-SUC, JAL-PRO, IZA-PET, QUE-TOT), en los cuales se utiliza directamente el valor de Google Maps.</a:t>
+            </a:r>
+          </a:p>
+          <a:p/>
+          <a:p>
+            <a:r>
+              <a:t>Un caso crítico fue la arista Izabal–Petén de 287.0 km por la CA-13: OSRM arrojaba 387.1 km por un trazado indirecto, por lo que adoptar el valor oficial de Google Maps evita desviar las encomiendas por Alta Verapaz. Cada número en nuestro sistema proviene de carreteras reales de Guatemala debidamente auditadas.</a:t>
             </a:r>
           </a:p>
         </p:txBody>
@@ -1054,7 +1060,7 @@
           <a:lstStyle/>
           <a:p>
             <a:r>
-              <a:t>Para calcular la mejor ruta para cada paquete implementamos el Algoritmo de Dijkstra. Su funcionamiento se basa en una estrategia voraz o greedy: a partir de la cabecera origen, examina las aristas adyacentes y relaja las distancias tentativas hacia los vecinos. Gracias a una cola de prioridad basada en min-heap binario, su complejidad temporal es de O((V+E) log V), resolviendo cualquier consulta en menos de 5 milisegundos en el navegador.</a:t>
+              <a:t>Para calcular la mejor ruta para cada paquete implementamos el Algoritmo de Dijkstra. Su funcionamiento se basa en una estrategia voraz o greedy: a partir de la cabecera origen, examina las aristas adyacentes y relaja las distancias tentativas hacia los vecinos. Gracias a una cola de prioridad basada en min-heap binario, su complejidad temporal es de O((V+E) log V).</a:t>
             </a:r>
           </a:p>
           <a:p/>
@@ -1130,13 +1136,44 @@
           <a:lstStyle/>
           <a:p>
             <a:r>
-              <a:t>Veamos nuestro primer caso de demostración: un envío transversal de costa a costa, desde Quetzaltenango en el altiplano occidental hasta Puerto Barrios, Izabal en el litoral atlántico.</a:t>
+              <a:t>Veamos nuestro primer caso de demostración: un envío desde Quetzaltenango hasta Puerto Barrios, Izabal.</a:t>
             </a:r>
           </a:p>
           <a:p/>
           <a:p>
             <a:r>
-              <a:t>El sistema determina una distancia óptima de 494.0 km a través de 5 tramos interdepartamentales: sale de Quetzaltenango por la RN-01 a Totonicapán (28.8 km), avanza a Quiché (36.2 km), enlaza por Baja Verapaz (128.6 km) y Zacapa (128.3 km), y se incorpora a la CA-9 Norte hasta Puerto Barrios (172.1 km). La interfaz no solo resalta la ruta en púrpura en el mapa interactivo, sino que desglosa cada tramo con su nomenclatura oficial y presenta la fórmula aritmética explícita de la suma para total transparencia.</a:t>
+              <a:t>El sistema determina una distancia óptima de 494.0 km a través de 5 tramos interdepartamentales:</a:t>
+            </a:r>
+          </a:p>
+          <a:p>
+            <a:r>
+              <a:t>1. QUE → TOT: 28.8 km por RN-1 / RN-1B</a:t>
+            </a:r>
+          </a:p>
+          <a:p>
+            <a:r>
+              <a:t>2. TOT → QUI: 36.2 km por RD QUI-04</a:t>
+            </a:r>
+          </a:p>
+          <a:p>
+            <a:r>
+              <a:t>3. QUI → BVE: 128.6 km por RD QUI-2 / RN-5</a:t>
+            </a:r>
+          </a:p>
+          <a:p>
+            <a:r>
+              <a:t>4. BVE → ZAC: 128.3 km por CA-9 Nor / CA-14</a:t>
+            </a:r>
+          </a:p>
+          <a:p>
+            <a:r>
+              <a:t>5. ZAC → IZA: 172.1 km por CA-9 Nor</a:t>
+            </a:r>
+          </a:p>
+          <a:p/>
+          <a:p>
+            <a:r>
+              <a:t>La interfaz resalta la ruta sobre el mapa interactivo, desglosa cada tramo con su carretera oficial y presenta la fórmula aritmética de comprobación.</a:t>
             </a:r>
           </a:p>
         </p:txBody>
@@ -1206,13 +1243,59 @@
           <a:lstStyle/>
           <a:p>
             <a:r>
-              <a:t>En el segundo ejemplo resolvemos el corredor norte: Ciudad de Guatemala a Flores, Petén. La ruta óptima es de 415.3 km recorriendo la CA-14 hacia Cobán y empalmando directamente con Petén a través de la Franja Transversal del Norte (RD PET-11, 257.3 km). El sistema preserva la geografía real norte-arriba sin deformación.</a:t>
+              <a:t>En la Demo 2 resolvemos el corredor norte: Ciudad de Guatemala a Flores, Petén. La ruta óptima es de 415.3 km recorriendo tres tramos:</a:t>
+            </a:r>
+          </a:p>
+          <a:p>
+            <a:r>
+              <a:t>- GUA → BVE: 89.0 km por RD BV-12 / RD GUA-12</a:t>
+            </a:r>
+          </a:p>
+          <a:p>
+            <a:r>
+              <a:t>- BVE → AVE: 69.0 km por CA-14 / RN-5</a:t>
+            </a:r>
+          </a:p>
+          <a:p>
+            <a:r>
+              <a:t>- AVE → PET: 257.3 km por RD PET-11 / RD AV-09</a:t>
             </a:r>
           </a:p>
           <a:p/>
           <a:p>
             <a:r>
-              <a:t>En el tercer ejemplo conectamos el extremo occidental fronterizo de San Marcos con Jutiapa en el oriente, cruzando el país por la costa sur con un total de 368.3 km: desciende por la CITO-180 hacia Mazatenango, conecta con Escuintla y Santa Rosa por la CA-2 Occidente y culmina en Jutiapa por la CA-1 Oriente. Ambas rutas demuestran que el sistema encuentra de forma infalible la distancia mínima.</a:t>
+              <a:t>En la Demo 3 conectamos San Marcos con Jutiapa, totalizando 368.3 km a través de cinco tramos:</a:t>
+            </a:r>
+          </a:p>
+          <a:p>
+            <a:r>
+              <a:t>- SMA → QUE: 49.6 km por RN-1</a:t>
+            </a:r>
+          </a:p>
+          <a:p>
+            <a:r>
+              <a:t>- QUE → SUC: 60.2 km por CITO-180 / SCH-02</a:t>
+            </a:r>
+          </a:p>
+          <a:p>
+            <a:r>
+              <a:t>- SUC → ESC: 102.5 km por CA-02 OCC</a:t>
+            </a:r>
+          </a:p>
+          <a:p>
+            <a:r>
+              <a:t>- ESC → SRO: 100.0 km por CA-2 OR / RN-16</a:t>
+            </a:r>
+          </a:p>
+          <a:p>
+            <a:r>
+              <a:t>- SRO → JUT: 56.0 km por CA-1 Or</a:t>
+            </a:r>
+          </a:p>
+          <a:p/>
+          <a:p>
+            <a:r>
+              <a:t>Ambas rutas demuestran que el sistema encuentra de forma infalible la distancia mínima con las carreteras exactas del modelo.</a:t>
             </a:r>
           </a:p>
         </p:txBody>
@@ -1375,7 +1458,7 @@
           </a:p>
           <a:p>
             <a:r>
-              <a:t>2. Un Administrador de Red completo para agregar, editar o deshabilitar departamentos y carreteras con validación de conexidad en tiempo real.</a:t>
+              <a:t>2. Un Administrador de Red para agregar, editar, eliminar y buscar departamentos y carreteras con validaciones; al eliminar una carretera la ruta se recalcula al instante y se muestra un aviso si la red queda desconectada.</a:t>
             </a:r>
           </a:p>
           <a:p>
@@ -4653,7 +4736,7 @@
               </a:defRPr>
             </a:pPr>
             <a:r>
-              <a:t>Semestre: 6.º semestre, Sección A</a:t>
+              <a:t>Semestre: 6.º semestre, Ingeniería en Sistemas</a:t>
             </a:r>
           </a:p>
           <a:p>
@@ -5213,7 +5296,7 @@
             </a:r>
             <a:br/>
             <a:r>
-              <a:t>• Aprobación del 100 % en Chromium, WebKit (Safari), Firefox y vista móvil.</a:t>
+              <a:t>• Pruebas ejecutadas en Desktop Chrome, iPhone 13 (WebKit), Pixel 7 e iPad.</a:t>
             </a:r>
           </a:p>
         </p:txBody>
@@ -6012,7 +6095,7 @@
               </a:defRPr>
             </a:pPr>
             <a:r>
-              <a:t>• Arquitectura modular 100 % TypeScript ejecutable en navegador con respuesta en &lt; 5 ms.</a:t>
+              <a:t>• Arquitectura modular 100 % TypeScript, reactiva y ejecutable directamente en el navegador.</a:t>
             </a:r>
             <a:br/>
             <a:r>
@@ -8054,11 +8137,11 @@
               </a:defRPr>
             </a:pPr>
             <a:r>
-              <a:t>Coincidencia Idéntica</a:t>
+              <a:t>Ruta Recomendada</a:t>
             </a:r>
             <a:br/>
             <a:r>
-              <a:t>(Δ = 0 km)</a:t>
+              <a:t>(OSRM a ±10 %)</a:t>
             </a:r>
           </a:p>
         </p:txBody>
@@ -8152,11 +8235,11 @@
               </a:defRPr>
             </a:pPr>
             <a:r>
-              <a:t>Variación Mínima</a:t>
+              <a:t>Ruta Alternativa</a:t>
             </a:r>
             <a:br/>
             <a:r>
-              <a:t>(Δ ≤ 2 km)</a:t>
+              <a:t>(OSRM a ±10 %)</a:t>
             </a:r>
           </a:p>
         </p:txBody>
@@ -8250,11 +8333,11 @@
               </a:defRPr>
             </a:pPr>
             <a:r>
-              <a:t>Ajuste Urbano</a:t>
+              <a:t>Valor Google Maps</a:t>
             </a:r>
             <a:br/>
             <a:r>
-              <a:t>(Documentado)</a:t>
+              <a:t>(Sin coincidencia)</a:t>
             </a:r>
           </a:p>
         </p:txBody>
@@ -8361,7 +8444,7 @@
               </a:defRPr>
             </a:pPr>
             <a:r>
-              <a:t>• Auditoría Manual 49/49: Cada una de las 49 carreteras fue medida y contrastada punto a punto en Google Maps.</a:t>
+              <a:t>• Auditoría 49/49 en Google Maps: Cada una de las 49 carreteras fue validada punto a punto en Google Maps.</a:t>
             </a:r>
           </a:p>
           <a:p>
@@ -8374,7 +8457,7 @@
               </a:defRPr>
             </a:pPr>
             <a:r>
-              <a:t>• Alineación 100 % Confiable: 44 de 49 tramos (89.8 %) tienen desviación nula o insignificante (≤ 2 km).</a:t>
+              <a:t>• Tolerancia ±10 %: 35 tramos coinciden con la ruta recomendada y 9 con una ruta alternativa de Google Maps.</a:t>
             </a:r>
           </a:p>
           <a:p>
@@ -8387,7 +8470,7 @@
               </a:defRPr>
             </a:pPr>
             <a:r>
-              <a:t>• Caso Crítico IZA–PET (287.0 km): Conexión directa por la CA-13. Sin este tramo troncal, cualquier algoritmo desviaría las encomiendas por Alta Verapaz sumando cientos de kilómetros erróneos.</a:t>
+              <a:t>• 5 Tramos Ajustados a Google Maps: Al no coincidir OSRM a ±10 %, se usa el valor de Google Maps (CHI-SOL, CHI-SUC, JAL-PRO, IZA-PET, QUE-TOT).</a:t>
             </a:r>
           </a:p>
           <a:p>
@@ -8400,7 +8483,7 @@
               </a:defRPr>
             </a:pPr>
             <a:r>
-              <a:t>• Transparencia: Todas las aristas y sus fuentes se documentan en el repositorio institucional.</a:t>
+              <a:t>• Caso Crítico IZA–PET (287.0 km): Conexión directa por la CA-13 adoptada de Google Maps (OSRM daba 387.1 km) para evitar desvíos falsos por Alta Verapaz.</a:t>
             </a:r>
           </a:p>
         </p:txBody>
@@ -8901,10 +8984,6 @@
             </a:r>
             <a:br/>
             <a:r>
-              <a:t>• Rendimiento: Resuelve la consulta en el navegador en &lt; 5 milisegundos.</a:t>
-            </a:r>
-            <a:br/>
-            <a:r>
               <a:t>• ¿Por qué NO admite pesos negativos?</a:t>
             </a:r>
             <a:br/>
@@ -9492,7 +9571,7 @@
               </a:defRPr>
             </a:pPr>
             <a:r>
-              <a:t>• 1. QUE → TOT: 28.8 km — RN-01 (Quetzaltenango a Totonicapán)</a:t>
+              <a:t>• 1. QUE → TOT: 28.8 km — RN-1 / RN-1B</a:t>
             </a:r>
           </a:p>
           <a:p>
@@ -9505,7 +9584,7 @@
               </a:defRPr>
             </a:pPr>
             <a:r>
-              <a:t>• 2. TOT → QUI: 36.2 km — RN-15 (Totonicapán a Quiché)</a:t>
+              <a:t>• 2. TOT → QUI: 36.2 km — RD QUI-04</a:t>
             </a:r>
           </a:p>
           <a:p>
@@ -9518,7 +9597,7 @@
               </a:defRPr>
             </a:pPr>
             <a:r>
-              <a:t>• 3. QUI → BVE: 128.6 km — RN-15 (Santa Cruz del Quiché a Salamá)</a:t>
+              <a:t>• 3. QUI → BVE: 128.6 km — RD QUI-2 / RN-5</a:t>
             </a:r>
           </a:p>
           <a:p>
@@ -9531,7 +9610,7 @@
               </a:defRPr>
             </a:pPr>
             <a:r>
-              <a:t>• 4. BVE → ZAC: 128.3 km — RN-17 / CA-09 (Salamá a Zacapa)</a:t>
+              <a:t>• 4. BVE → ZAC: 128.3 km — CA-9 Nor / CA-14</a:t>
             </a:r>
           </a:p>
           <a:p>
@@ -9544,7 +9623,7 @@
               </a:defRPr>
             </a:pPr>
             <a:r>
-              <a:t>• 5. ZAC → IZA: 172.1 km — CA-09 Norte (Zacapa a Puerto Barrios)</a:t>
+              <a:t>• 5. ZAC → IZA: 172.1 km — CA-9 Nor</a:t>
             </a:r>
           </a:p>
         </p:txBody>
@@ -9639,19 +9718,6 @@
             </a:pPr>
             <a:r>
               <a:t>28.8 + 36.2 + 128.6 + 128.3 + 172.1 = 494.0 km</a:t>
-            </a:r>
-          </a:p>
-          <a:p>
-            <a:pPr>
-              <a:defRPr sz="950">
-                <a:solidFill>
-                  <a:srgbClr val="94A3B8"/>
-                </a:solidFill>
-                <a:latin typeface="Segoe UI"/>
-              </a:defRPr>
-            </a:pPr>
-            <a:r>
-              <a:t>Evita el paso por la Ciudad de Guatemala, ahorrando 60+ km y horas de congestión.</a:t>
             </a:r>
           </a:p>
         </p:txBody>
@@ -10050,15 +10116,15 @@
             </a:r>
             <a:br/>
             <a:r>
-              <a:t>    - GUA → BVE: 89.0 km (CA-09 Norte a Salamá)</a:t>
+              <a:t>    - GUA → BVE: 89.0 km (RD BV-12 / RD GUA-12)</a:t>
             </a:r>
             <a:br/>
             <a:r>
-              <a:t>    - BVE → AVE: 69.0 km (CA-14 hacia Cobán)</a:t>
+              <a:t>    - BVE → AVE: 69.0 km (CA-14 / RN-5)</a:t>
             </a:r>
             <a:br/>
             <a:r>
-              <a:t>    - AVE → PET: 257.3 km (Franja Transversal del Norte RD PET-11)</a:t>
+              <a:t>    - AVE → PET: 257.3 km (RD PET-11 / RD AV-09)</a:t>
             </a:r>
             <a:br/>
             <a:r>
@@ -10273,15 +10339,15 @@
             </a:r>
             <a:br/>
             <a:r>
-              <a:t>    - SMA → QUE: 49.6 km (RN-01)  |  QUE → SUC: 60.2 km (CITO-180)</a:t>
+              <a:t>    - SMA → QUE: 49.6 km (RN-1)  |  QUE → SUC: 60.2 km (CITO-180 / SCH-02)</a:t>
             </a:r>
             <a:br/>
             <a:r>
-              <a:t>    - SUC → ESC: 102.5 km (CA-02)  |  ESC → SRO: 100.0 km (CA-02)</a:t>
+              <a:t>    - SUC → ESC: 102.5 km (CA-02 OCC)  |  ESC → SRO: 100.0 km (CA-2 OR / RN-16)</a:t>
             </a:r>
             <a:br/>
             <a:r>
-              <a:t>    - SRO → JUT: 56.0 km (CA-01 Oriente)</a:t>
+              <a:t>    - SRO → JUT: 56.0 km (CA-1 Or)</a:t>
             </a:r>
             <a:br/>
             <a:r>
@@ -11455,15 +11521,15 @@
               </a:defRPr>
             </a:pPr>
             <a:r>
-              <a:t>• Modales para agregar, modificar o deshabilitar cabeceras y carreteras.</a:t>
+              <a:t>• Agregar, editar, eliminar y buscar departamentos y carreteras con validaciones.</a:t>
             </a:r>
             <a:br/>
             <a:r>
-              <a:t>• Validación en vivo de conexidad territorial y topológica.</a:t>
+              <a:t>• Al eliminar una carretera la ruta se recalcula al instante.</a:t>
             </a:r>
             <a:br/>
             <a:r>
-              <a:t>• Capacidad de simular cierres viales o bloqueos y recalcular al instante.</a:t>
+              <a:t>• Aviso y alerta automática si la red vial queda desconectada.</a:t>
             </a:r>
           </a:p>
         </p:txBody>

</xml_diff>